<commit_message>
Néerlandais 1: deck generator for modules 11-15 (bloc 3), README for 15 modules
Adds m11-m15 (particle verbs, modal verbs, negation, word formation,
perfect tense with the final course review), sets the cover chip to
'MODULE N / 15' and rebuilds decks 1-10.

Co-Authored-By: Claude Opus 5.5 <noreply@anthropic.com>
Claude-Session: https://claude.ai/code/session_01GHo9GbchfMk8JhTz1kwo92
</commit_message>
<xml_diff>
--- a/neerlandais1/powerpoints/Module_10_Een_mail_opstellen.pptx
+++ b/neerlandais1/powerpoints/Module_10_Een_mail_opstellen.pptx
@@ -136,19 +136,19 @@
   <p:extLst>
     <p:ext uri="{521415D9-36F7-43E2-AB2F-B90AF26B5E84}">
       <p14:sectionLst xmlns:p14="http://schemas.microsoft.com/office/powerpoint/2010/main">
-        <p14:section name="Ouverture" id="{cde8dc9d-9cd8-abfd-c47e-f1cc5432d600}">
+        <p14:section name="Ouverture" id="{a646d040-ed4d-463e-7c0f-9d78e48438c7}">
           <p14:sldIdLst>
             <p14:sldId id="256"/>
           </p14:sldIdLst>
         </p14:section>
-        <p14:section name="Découvrir" id="{9c357161-1278-e8f7-bf5f-cf5634a30fa4}">
+        <p14:section name="Découvrir" id="{066a9f91-a6bd-fd68-71f2-f1f0684da338}">
           <p14:sldIdLst>
             <p14:sldId id="257"/>
             <p14:sldId id="258"/>
             <p14:sldId id="259"/>
           </p14:sldIdLst>
         </p14:section>
-        <p14:section name="Comprendre" id="{058a7c55-9c7f-4db4-eca8-888ae2e17c62}">
+        <p14:section name="Comprendre" id="{03b8a698-1905-a712-c7a1-c609aefb6b87}">
           <p14:sldIdLst>
             <p14:sldId id="260"/>
             <p14:sldId id="261"/>
@@ -162,7 +162,7 @@
             <p14:sldId id="269"/>
           </p14:sldIdLst>
         </p14:section>
-        <p14:section name="JIJ NU ! — Oefeningen" id="{3458fb03-11f0-8bed-3286-cd62487747f5}">
+        <p14:section name="JIJ NU ! — Oefeningen" id="{13115117-f793-f24b-1020-97146129f03f}">
           <p14:sldIdLst>
             <p14:sldId id="270"/>
             <p14:sldId id="271"/>
@@ -181,7 +181,7 @@
             <p14:sldId id="284"/>
           </p14:sldIdLst>
         </p14:section>
-        <p14:section name="Clôture" id="{d0c73b51-c288-9c5c-f27d-a306fa8b70ea}">
+        <p14:section name="Clôture" id="{e2487b3b-76b7-ee39-ae86-f1e83fd7c406}">
           <p14:sldIdLst>
             <p14:sldId id="285"/>
           </p14:sldIdLst>
@@ -2198,7 +2198,7 @@
             <a:r>
               <a:rPr lang="en-US" dirty="0"/>
               <a:t>Objectif : Rédiger un e-mail complet à partir d'une situation (reprise des situations de l'archive, ramenées à l'A1).
-Chaque apprenant choisit une situation F et une situation I. Les modèles sont au présent : le passé composé (Ik heb … besteld) est vu en Néerlandais 2. Faites échanger les e-mails : le voisin corrige avec la checklist.</a:t>
+Chaque apprenant choisit une situation F et une situation I. Les modèles sont au présent : le passé composé (Ik heb … besteld) est vu au M15. Faites échanger les e-mails : le voisin corrige avec la checklist.</a:t>
             </a:r>
             <a:endParaRPr lang="en-US" dirty="0"/>
           </a:p>
@@ -2288,7 +2288,7 @@
               <a:rPr lang="en-US" dirty="0"/>
               <a:t>CORRIGÉ — révélez les réponses une à une, en faisant justifier chaque choix.
 Objectif : Rédiger un e-mail complet à partir d'une situation (reprise des situations de l'archive, ramenées à l'A1).
-Chaque apprenant choisit une situation F et une situation I. Les modèles sont au présent : le passé composé (Ik heb … besteld) est vu en Néerlandais 2. Faites échanger les e-mails : le voisin corrige avec la checklist.</a:t>
+Chaque apprenant choisit une situation F et une situation I. Les modèles sont au présent : le passé composé (Ik heb … besteld) est vu au M15. Faites échanger les e-mails : le voisin corrige avec la checklist.</a:t>
             </a:r>
             <a:endParaRPr lang="en-US" dirty="0"/>
           </a:p>
@@ -2644,12 +2644,12 @@
           <a:p>
             <a:r>
               <a:rPr lang="en-US" dirty="0"/>
-              <a:t>Objectif : Vérifier les 3 objectifs du module et clore le parcours Néerlandais 1.
+              <a:t>Objectif : Vérifier les 3 objectifs du module et clore le bloc 2.
 Réponses :
 1. Geachte heer, geachte mevrouw, (ou Geachte heer / mevrouw + nom).
 2. Met vriendelijke groet.
 3. Beste meneer Maes, (ou Geachte heer Maes,) ↵ Ik stuur u de factuur. (virgule, ligne vide, majuscule)
-Bilan : faites relire à chacun la frise des 10 modules et choisir le module à retravailler. En Néerlandais 2 : le passé, les relatives, om … te, l'adjectif et les autres conjonctions.</a:t>
+Bilan : faites relire à chacun la frise des 10 modules et choisir le module à retravailler. Le bloc 3 approfondit le verbe et la phrase : verbes à particule, modaux, négation, formation des mots et passé composé.</a:t>
             </a:r>
             <a:endParaRPr lang="en-US" dirty="0"/>
           </a:p>
@@ -4081,7 +4081,7 @@
                   <a:srgbClr val="FFFFFF"/>
                 </a:solidFill>
               </a:rPr>
-              <a:t>MODULE 10 / 10</a:t>
+              <a:t>MODULE 10 / 15</a:t>
             </a:r>
             <a:endParaRPr lang="en-US" sz="1400" dirty="0"/>
           </a:p>
@@ -32742,7 +32742,7 @@
                   <a:schemeClr val="tx2"/>
                 </a:solidFill>
               </a:rPr>
-              <a:t>Ticket de sortie et bilan du parcours</a:t>
+              <a:t>Ticket de sortie et bilan du bloc 2</a:t>
             </a:r>
             <a:endParaRPr lang="en-US" sz="3000" dirty="0"/>
           </a:p>
@@ -33698,7 +33698,7 @@
                   <a:schemeClr val="bg1"/>
                 </a:solidFill>
               </a:rPr>
-              <a:t>Proficiat! Néerlandais 1 is klaar.</a:t>
+              <a:t>Proficiat! Bloc 1 en 2 zijn klaar.</a:t>
             </a:r>
             <a:r>
               <a:rPr lang="en-US" sz="1800" dirty="0">
@@ -33706,7 +33706,7 @@
                   <a:schemeClr val="bg1"/>
                 </a:solidFill>
               </a:rPr>
-              <a:t> — Volgende stap : Néerlandais 2</a:t>
+              <a:t> — Volgende stap : bloc 3, M11 Scheidbare werkwoorden</a:t>
             </a:r>
             <a:endParaRPr lang="en-US" sz="1800" dirty="0"/>
           </a:p>
@@ -33742,7 +33742,7 @@
                   <a:schemeClr val="accent5"/>
                 </a:solidFill>
               </a:rPr>
-              <a:t>LE PARCOURS</a:t>
+              <a:t>BLOCS 1 ET 2</a:t>
             </a:r>
             <a:endParaRPr lang="en-US" sz="1200" dirty="0"/>
           </a:p>

</xml_diff>

<commit_message>
Néerlandais 1: rebuild decks 1-15 (MODULE N / 19, M15 closes bloc 3)
Co-Authored-By: Claude Opus 5.5 <noreply@anthropic.com>
Claude-Session: https://claude.ai/code/session_01GHo9GbchfMk8JhTz1kwo92
</commit_message>
<xml_diff>
--- a/neerlandais1/powerpoints/Module_10_Een_mail_opstellen.pptx
+++ b/neerlandais1/powerpoints/Module_10_Een_mail_opstellen.pptx
@@ -136,19 +136,19 @@
   <p:extLst>
     <p:ext uri="{521415D9-36F7-43E2-AB2F-B90AF26B5E84}">
       <p14:sectionLst xmlns:p14="http://schemas.microsoft.com/office/powerpoint/2010/main">
-        <p14:section name="Ouverture" id="{a646d040-ed4d-463e-7c0f-9d78e48438c7}">
+        <p14:section name="Ouverture" id="{964f468a-5a8c-db7b-037a-71c639254292}">
           <p14:sldIdLst>
             <p14:sldId id="256"/>
           </p14:sldIdLst>
         </p14:section>
-        <p14:section name="Découvrir" id="{066a9f91-a6bd-fd68-71f2-f1f0684da338}">
+        <p14:section name="Découvrir" id="{e4be576c-102d-fdf6-9ef1-d055586cc8bb}">
           <p14:sldIdLst>
             <p14:sldId id="257"/>
             <p14:sldId id="258"/>
             <p14:sldId id="259"/>
           </p14:sldIdLst>
         </p14:section>
-        <p14:section name="Comprendre" id="{03b8a698-1905-a712-c7a1-c609aefb6b87}">
+        <p14:section name="Comprendre" id="{08ebde9c-ac74-cca6-73c6-c557e824370f}">
           <p14:sldIdLst>
             <p14:sldId id="260"/>
             <p14:sldId id="261"/>
@@ -162,7 +162,7 @@
             <p14:sldId id="269"/>
           </p14:sldIdLst>
         </p14:section>
-        <p14:section name="JIJ NU ! — Oefeningen" id="{13115117-f793-f24b-1020-97146129f03f}">
+        <p14:section name="JIJ NU ! — Oefeningen" id="{addb8282-0346-9ef5-9d23-f3c0aa2304a6}">
           <p14:sldIdLst>
             <p14:sldId id="270"/>
             <p14:sldId id="271"/>
@@ -181,7 +181,7 @@
             <p14:sldId id="284"/>
           </p14:sldIdLst>
         </p14:section>
-        <p14:section name="Clôture" id="{e2487b3b-76b7-ee39-ae86-f1e83fd7c406}">
+        <p14:section name="Clôture" id="{78334b2e-472f-a82e-cdc7-b5e708a5ab68}">
           <p14:sldIdLst>
             <p14:sldId id="285"/>
           </p14:sldIdLst>
@@ -4081,7 +4081,7 @@
                   <a:srgbClr val="FFFFFF"/>
                 </a:solidFill>
               </a:rPr>
-              <a:t>MODULE 10 / 15</a:t>
+              <a:t>MODULE 10 / 19</a:t>
             </a:r>
             <a:endParaRPr lang="en-US" sz="1400" dirty="0"/>
           </a:p>

</xml_diff>

<commit_message>
Néerlandais 1: PowerPoint decks for bloc 5 (M20-M24) and Dutch review fixes
Builds the five new decks and rebuilds M1-M19 (cover chip now reads / 24,
M19 closes bloc 4). Applies the Dutch review: zo'n/elk without -e,
Franse/Engelse, iets wat/dat, er... mee word order, particle placement,
hoor after ja/nee, Flemish nu, and several Belgian-usage notes.

Co-Authored-By: Claude Opus 5.5 <noreply@anthropic.com>
Claude-Session: https://claude.ai/code/session_01GHo9GbchfMk8JhTz1kwo92
</commit_message>
<xml_diff>
--- a/neerlandais1/powerpoints/Module_10_Een_mail_opstellen.pptx
+++ b/neerlandais1/powerpoints/Module_10_Een_mail_opstellen.pptx
@@ -136,19 +136,19 @@
   <p:extLst>
     <p:ext uri="{521415D9-36F7-43E2-AB2F-B90AF26B5E84}">
       <p14:sectionLst xmlns:p14="http://schemas.microsoft.com/office/powerpoint/2010/main">
-        <p14:section name="Ouverture" id="{964f468a-5a8c-db7b-037a-71c639254292}">
+        <p14:section name="Ouverture" id="{d3d238a8-4705-2812-1523-3a57727d505f}">
           <p14:sldIdLst>
             <p14:sldId id="256"/>
           </p14:sldIdLst>
         </p14:section>
-        <p14:section name="Découvrir" id="{e4be576c-102d-fdf6-9ef1-d055586cc8bb}">
+        <p14:section name="Découvrir" id="{a8bafc3c-d0c8-874d-0810-3e4dae2aa380}">
           <p14:sldIdLst>
             <p14:sldId id="257"/>
             <p14:sldId id="258"/>
             <p14:sldId id="259"/>
           </p14:sldIdLst>
         </p14:section>
-        <p14:section name="Comprendre" id="{08ebde9c-ac74-cca6-73c6-c557e824370f}">
+        <p14:section name="Comprendre" id="{cfb86591-d7b1-8cc1-54c3-da4437b8d1c3}">
           <p14:sldIdLst>
             <p14:sldId id="260"/>
             <p14:sldId id="261"/>
@@ -162,7 +162,7 @@
             <p14:sldId id="269"/>
           </p14:sldIdLst>
         </p14:section>
-        <p14:section name="JIJ NU ! — Oefeningen" id="{addb8282-0346-9ef5-9d23-f3c0aa2304a6}">
+        <p14:section name="JIJ NU ! — Oefeningen" id="{62717555-10d7-1026-84c3-108377151fb1}">
           <p14:sldIdLst>
             <p14:sldId id="270"/>
             <p14:sldId id="271"/>
@@ -181,7 +181,7 @@
             <p14:sldId id="284"/>
           </p14:sldIdLst>
         </p14:section>
-        <p14:section name="Clôture" id="{78334b2e-472f-a82e-cdc7-b5e708a5ab68}">
+        <p14:section name="Clôture" id="{26245d44-ccc5-3a27-ae80-46ba216425b4}">
           <p14:sldIdLst>
             <p14:sldId id="285"/>
           </p14:sldIdLst>
@@ -4081,7 +4081,7 @@
                   <a:srgbClr val="FFFFFF"/>
                 </a:solidFill>
               </a:rPr>
-              <a:t>MODULE 10 / 19</a:t>
+              <a:t>MODULE 10 / 24</a:t>
             </a:r>
             <a:endParaRPr lang="en-US" sz="1400" dirty="0"/>
           </a:p>

</xml_diff>

<commit_message>
Bloc 6 : relecture du néerlandais et génération des 30 PowerPoint
Relecture M25–M29 appliquée :
- détectives : présentation M10 (Geachte heer, virgule puis majuscule,
  formule finale à la ligne), exactement 5 erreurs ;
- M29 : vrijaf geven, als je de baas was, kunnen verplaatsen ;
- M27 : Ik sport graag niet (place de niet), notes sur l'usage flamand ;
- M25 : kwartuur et Op welk uur? signalés comme usage belge oral,
  's namiddags, twintig voor acht accepté ;
- M26 : in 1995, forme courte twaalf euro vijftig ;
- M28 : mij réfléchi possible, Zet u! en Flandre.

Nouveaux decks M25–M29 ; tous les decks portent « MODULE n / 29 ».

Co-Authored-By: Claude Opus 5.5 <noreply@anthropic.com>
Claude-Session: https://claude.ai/code/session_01GHo9GbchfMk8JhTz1kwo92
</commit_message>
<xml_diff>
--- a/neerlandais1/powerpoints/Module_10_Een_mail_opstellen.pptx
+++ b/neerlandais1/powerpoints/Module_10_Een_mail_opstellen.pptx
@@ -136,19 +136,19 @@
   <p:extLst>
     <p:ext uri="{521415D9-36F7-43E2-AB2F-B90AF26B5E84}">
       <p14:sectionLst xmlns:p14="http://schemas.microsoft.com/office/powerpoint/2010/main">
-        <p14:section name="Ouverture" id="{d3d238a8-4705-2812-1523-3a57727d505f}">
+        <p14:section name="Ouverture" id="{3ccb3191-0ca2-0efe-7aef-e3c9d90bb600}">
           <p14:sldIdLst>
             <p14:sldId id="256"/>
           </p14:sldIdLst>
         </p14:section>
-        <p14:section name="Découvrir" id="{a8bafc3c-d0c8-874d-0810-3e4dae2aa380}">
+        <p14:section name="Découvrir" id="{cb824109-9a77-3128-16c6-48c7cfdedc6f}">
           <p14:sldIdLst>
             <p14:sldId id="257"/>
             <p14:sldId id="258"/>
             <p14:sldId id="259"/>
           </p14:sldIdLst>
         </p14:section>
-        <p14:section name="Comprendre" id="{cfb86591-d7b1-8cc1-54c3-da4437b8d1c3}">
+        <p14:section name="Comprendre" id="{d6eabc94-3faa-88da-dbee-59860c07ae34}">
           <p14:sldIdLst>
             <p14:sldId id="260"/>
             <p14:sldId id="261"/>
@@ -162,7 +162,7 @@
             <p14:sldId id="269"/>
           </p14:sldIdLst>
         </p14:section>
-        <p14:section name="JIJ NU ! — Oefeningen" id="{62717555-10d7-1026-84c3-108377151fb1}">
+        <p14:section name="JIJ NU ! — Oefeningen" id="{f7199675-d669-d6cc-abf8-f003a6dbb842}">
           <p14:sldIdLst>
             <p14:sldId id="270"/>
             <p14:sldId id="271"/>
@@ -181,7 +181,7 @@
             <p14:sldId id="284"/>
           </p14:sldIdLst>
         </p14:section>
-        <p14:section name="Clôture" id="{26245d44-ccc5-3a27-ae80-46ba216425b4}">
+        <p14:section name="Clôture" id="{378f8a65-bd31-921f-6a93-7dc78d6a124a}">
           <p14:sldIdLst>
             <p14:sldId id="285"/>
           </p14:sldIdLst>
@@ -4081,7 +4081,7 @@
                   <a:srgbClr val="FFFFFF"/>
                 </a:solidFill>
               </a:rPr>
-              <a:t>MODULE 10 / 24</a:t>
+              <a:t>MODULE 10 / 29</a:t>
             </a:r>
             <a:endParaRPr lang="en-US" sz="1400" dirty="0"/>
           </a:p>

</xml_diff>

<commit_message>
Bloc 7 : relecture du néerlandais et génération des 33 PowerPoint
Relecture M30–M32 appliquée :
- M30 : wacht ik op je ; BE de patroon ; « faire une présentation » →
  een presentatie geven ; de informaticus (= de IT'er) ;
- M31 : exemple de lieu avec lopen (Ik loop in de keuken), règle zijn
  limitée aux verbes de mouvement sans objet, vergaderzaal van de
  directie, u gaat de eerste deur links binnen, paire op de brug /
  de brug over, calque stijgen, lopen / stappen en Flandre ;
- M32 : Daarna werkte ik…, Leuk je te leren kennen, bij et sinds
  acceptés, l'enseigne fictive Bolero renommée Koopzo (M10, M28, M32).

Nouveaux decks M30–M32 ; tous les decks portent « MODULE n / 32 ».

Co-Authored-By: Claude Opus 5.5 <noreply@anthropic.com>
Claude-Session: https://claude.ai/code/session_01GHo9GbchfMk8JhTz1kwo92
</commit_message>
<xml_diff>
--- a/neerlandais1/powerpoints/Module_10_Een_mail_opstellen.pptx
+++ b/neerlandais1/powerpoints/Module_10_Een_mail_opstellen.pptx
@@ -136,19 +136,19 @@
   <p:extLst>
     <p:ext uri="{521415D9-36F7-43E2-AB2F-B90AF26B5E84}">
       <p14:sectionLst xmlns:p14="http://schemas.microsoft.com/office/powerpoint/2010/main">
-        <p14:section name="Ouverture" id="{3ccb3191-0ca2-0efe-7aef-e3c9d90bb600}">
+        <p14:section name="Ouverture" id="{7c0a8411-6d2b-258a-6d44-40128ac10148}">
           <p14:sldIdLst>
             <p14:sldId id="256"/>
           </p14:sldIdLst>
         </p14:section>
-        <p14:section name="Découvrir" id="{cb824109-9a77-3128-16c6-48c7cfdedc6f}">
+        <p14:section name="Découvrir" id="{40888c50-0c95-b7bc-2a99-6019b370e23c}">
           <p14:sldIdLst>
             <p14:sldId id="257"/>
             <p14:sldId id="258"/>
             <p14:sldId id="259"/>
           </p14:sldIdLst>
         </p14:section>
-        <p14:section name="Comprendre" id="{d6eabc94-3faa-88da-dbee-59860c07ae34}">
+        <p14:section name="Comprendre" id="{20cd233f-bd9a-3f30-da54-d95bfd09ef31}">
           <p14:sldIdLst>
             <p14:sldId id="260"/>
             <p14:sldId id="261"/>
@@ -162,7 +162,7 @@
             <p14:sldId id="269"/>
           </p14:sldIdLst>
         </p14:section>
-        <p14:section name="JIJ NU ! — Oefeningen" id="{f7199675-d669-d6cc-abf8-f003a6dbb842}">
+        <p14:section name="JIJ NU ! — Oefeningen" id="{8ff7811d-ef14-63e0-dbeb-cf887c3c9fa0}">
           <p14:sldIdLst>
             <p14:sldId id="270"/>
             <p14:sldId id="271"/>
@@ -181,7 +181,7 @@
             <p14:sldId id="284"/>
           </p14:sldIdLst>
         </p14:section>
-        <p14:section name="Clôture" id="{378f8a65-bd31-921f-6a93-7dc78d6a124a}">
+        <p14:section name="Clôture" id="{33743c47-4a8c-d643-b1a1-9b263a2bf545}">
           <p14:sldIdLst>
             <p14:sldId id="285"/>
           </p14:sldIdLst>
@@ -2556,7 +2556,7 @@
             <a:r>
               <a:rPr lang="en-US" dirty="0"/>
               <a:t>Objectif : Activer l'intuition du registre à partir de vrais objets d'e-mails.
-Demandez : « Formel (F) ou informel (I) ? Comment le savez-vous déjà, sans ouvrir le mail ? » Réponses : 1 I · 2 F · 3 F · 4 I · 5 F. Les indices : le prénom, le point d'interrogation familier, uw, le numéro de dossier. Bolero est une enseigne fictive.</a:t>
+Demandez : « Formel (F) ou informel (I) ? Comment le savez-vous déjà, sans ouvrir le mail ? » Réponses : 1 I · 2 F · 3 F · 4 I · 5 F. Les indices : le prénom, le point d'interrogation familier, uw, le numéro de dossier. Koopzo est une enseigne fictive.</a:t>
             </a:r>
             <a:endParaRPr lang="en-US" dirty="0"/>
           </a:p>
@@ -4081,7 +4081,7 @@
                   <a:srgbClr val="FFFFFF"/>
                 </a:solidFill>
               </a:rPr>
-              <a:t>MODULE 10 / 29</a:t>
+              <a:t>MODULE 10 / 32</a:t>
             </a:r>
             <a:endParaRPr lang="en-US" sz="1400" dirty="0"/>
           </a:p>
@@ -31903,7 +31903,7 @@
                   <a:schemeClr val="tx1"/>
                 </a:solidFill>
               </a:rPr>
-              <a:t>Webshop Bolero</a:t>
+              <a:t>Webshop Koopzo</a:t>
             </a:r>
             <a:endParaRPr lang="en-US" sz="1700" dirty="0"/>
           </a:p>

</xml_diff>

<commit_message>
Complément Chunks! : relecture du néerlandais et génération des 34 PowerPoint
Relecture appliquée : lettres pièges pour francophones (e, g, j) et
lettre y ajoutée ; dialogue Sofie / Karim cohérent ; het = « ça » ;
Ik ben 25 jaar dans le mot à mot ; Hallo neutre / Hoi familier ;
Nog een fijne dag! ; Wat doe je van beroep? ; fiche avec voornaam et
familienaam ; notes sur even, kan je / kun je, Wablieft, Ik weet het
niet ; les 10 blocs indispensables.

Co-Authored-By: Claude Opus 5.5 <noreply@anthropic.com>
Claude-Session: https://claude.ai/code/session_01GHo9GbchfMk8JhTz1kwo92
</commit_message>
<xml_diff>
--- a/neerlandais1/powerpoints/Module_10_Een_mail_opstellen.pptx
+++ b/neerlandais1/powerpoints/Module_10_Een_mail_opstellen.pptx
@@ -136,19 +136,19 @@
   <p:extLst>
     <p:ext uri="{521415D9-36F7-43E2-AB2F-B90AF26B5E84}">
       <p14:sectionLst xmlns:p14="http://schemas.microsoft.com/office/powerpoint/2010/main">
-        <p14:section name="Ouverture" id="{7c0a8411-6d2b-258a-6d44-40128ac10148}">
+        <p14:section name="Ouverture" id="{9b349cee-2d79-0f64-7fed-97454a11a492}">
           <p14:sldIdLst>
             <p14:sldId id="256"/>
           </p14:sldIdLst>
         </p14:section>
-        <p14:section name="Découvrir" id="{40888c50-0c95-b7bc-2a99-6019b370e23c}">
+        <p14:section name="Découvrir" id="{6f098c52-228c-295e-52ac-640107e193a0}">
           <p14:sldIdLst>
             <p14:sldId id="257"/>
             <p14:sldId id="258"/>
             <p14:sldId id="259"/>
           </p14:sldIdLst>
         </p14:section>
-        <p14:section name="Comprendre" id="{20cd233f-bd9a-3f30-da54-d95bfd09ef31}">
+        <p14:section name="Comprendre" id="{ccaf5011-5dad-9aa8-b26c-108187a6f036}">
           <p14:sldIdLst>
             <p14:sldId id="260"/>
             <p14:sldId id="261"/>
@@ -162,7 +162,7 @@
             <p14:sldId id="269"/>
           </p14:sldIdLst>
         </p14:section>
-        <p14:section name="JIJ NU ! — Oefeningen" id="{8ff7811d-ef14-63e0-dbeb-cf887c3c9fa0}">
+        <p14:section name="JIJ NU ! — Oefeningen" id="{2dd41d47-a950-2da4-eed8-3776a5688a8f}">
           <p14:sldIdLst>
             <p14:sldId id="270"/>
             <p14:sldId id="271"/>
@@ -181,7 +181,7 @@
             <p14:sldId id="284"/>
           </p14:sldIdLst>
         </p14:section>
-        <p14:section name="Clôture" id="{33743c47-4a8c-d643-b1a1-9b263a2bf545}">
+        <p14:section name="Clôture" id="{ce0362c6-6f2d-4b70-8baf-5c8525f3bcbb}">
           <p14:sldIdLst>
             <p14:sldId id="285"/>
           </p14:sldIdLst>

</xml_diff>